<commit_message>
major update - adding custom fields, conditional badge colors, labels and refinements
</commit_message>
<xml_diff>
--- a/write-up/icons and images.pptx
+++ b/write-up/icons and images.pptx
@@ -530,7 +530,7 @@
           <a:p>
             <a:fld id="{54D2636B-93AE-4EE8-9634-9602CF1FCC67}" type="datetimeFigureOut">
               <a:rPr lang="en-US" smtClean="0"/>
-              <a:t>10/11/2025</a:t>
+              <a:t>12/15/2025</a:t>
             </a:fld>
             <a:endParaRPr lang="en-US"/>
           </a:p>
@@ -728,7 +728,7 @@
           <a:p>
             <a:fld id="{54D2636B-93AE-4EE8-9634-9602CF1FCC67}" type="datetimeFigureOut">
               <a:rPr lang="en-US" smtClean="0"/>
-              <a:t>10/11/2025</a:t>
+              <a:t>12/15/2025</a:t>
             </a:fld>
             <a:endParaRPr lang="en-US"/>
           </a:p>
@@ -936,7 +936,7 @@
           <a:p>
             <a:fld id="{54D2636B-93AE-4EE8-9634-9602CF1FCC67}" type="datetimeFigureOut">
               <a:rPr lang="en-US" smtClean="0"/>
-              <a:t>10/11/2025</a:t>
+              <a:t>12/15/2025</a:t>
             </a:fld>
             <a:endParaRPr lang="en-US"/>
           </a:p>
@@ -1134,7 +1134,7 @@
           <a:p>
             <a:fld id="{54D2636B-93AE-4EE8-9634-9602CF1FCC67}" type="datetimeFigureOut">
               <a:rPr lang="en-US" smtClean="0"/>
-              <a:t>10/11/2025</a:t>
+              <a:t>12/15/2025</a:t>
             </a:fld>
             <a:endParaRPr lang="en-US"/>
           </a:p>
@@ -1409,7 +1409,7 @@
           <a:p>
             <a:fld id="{54D2636B-93AE-4EE8-9634-9602CF1FCC67}" type="datetimeFigureOut">
               <a:rPr lang="en-US" smtClean="0"/>
-              <a:t>10/11/2025</a:t>
+              <a:t>12/15/2025</a:t>
             </a:fld>
             <a:endParaRPr lang="en-US"/>
           </a:p>
@@ -1674,7 +1674,7 @@
           <a:p>
             <a:fld id="{54D2636B-93AE-4EE8-9634-9602CF1FCC67}" type="datetimeFigureOut">
               <a:rPr lang="en-US" smtClean="0"/>
-              <a:t>10/11/2025</a:t>
+              <a:t>12/15/2025</a:t>
             </a:fld>
             <a:endParaRPr lang="en-US"/>
           </a:p>
@@ -2086,7 +2086,7 @@
           <a:p>
             <a:fld id="{54D2636B-93AE-4EE8-9634-9602CF1FCC67}" type="datetimeFigureOut">
               <a:rPr lang="en-US" smtClean="0"/>
-              <a:t>10/11/2025</a:t>
+              <a:t>12/15/2025</a:t>
             </a:fld>
             <a:endParaRPr lang="en-US"/>
           </a:p>
@@ -2227,7 +2227,7 @@
           <a:p>
             <a:fld id="{54D2636B-93AE-4EE8-9634-9602CF1FCC67}" type="datetimeFigureOut">
               <a:rPr lang="en-US" smtClean="0"/>
-              <a:t>10/11/2025</a:t>
+              <a:t>12/15/2025</a:t>
             </a:fld>
             <a:endParaRPr lang="en-US"/>
           </a:p>
@@ -2340,7 +2340,7 @@
           <a:p>
             <a:fld id="{54D2636B-93AE-4EE8-9634-9602CF1FCC67}" type="datetimeFigureOut">
               <a:rPr lang="en-US" smtClean="0"/>
-              <a:t>10/11/2025</a:t>
+              <a:t>12/15/2025</a:t>
             </a:fld>
             <a:endParaRPr lang="en-US"/>
           </a:p>
@@ -2651,7 +2651,7 @@
           <a:p>
             <a:fld id="{54D2636B-93AE-4EE8-9634-9602CF1FCC67}" type="datetimeFigureOut">
               <a:rPr lang="en-US" smtClean="0"/>
-              <a:t>10/11/2025</a:t>
+              <a:t>12/15/2025</a:t>
             </a:fld>
             <a:endParaRPr lang="en-US"/>
           </a:p>
@@ -2939,7 +2939,7 @@
           <a:p>
             <a:fld id="{54D2636B-93AE-4EE8-9634-9602CF1FCC67}" type="datetimeFigureOut">
               <a:rPr lang="en-US" smtClean="0"/>
-              <a:t>10/11/2025</a:t>
+              <a:t>12/15/2025</a:t>
             </a:fld>
             <a:endParaRPr lang="en-US"/>
           </a:p>
@@ -3180,7 +3180,7 @@
           <a:p>
             <a:fld id="{54D2636B-93AE-4EE8-9634-9602CF1FCC67}" type="datetimeFigureOut">
               <a:rPr lang="en-US" smtClean="0"/>
-              <a:t>10/11/2025</a:t>
+              <a:t>12/15/2025</a:t>
             </a:fld>
             <a:endParaRPr lang="en-US"/>
           </a:p>
@@ -4102,7 +4102,7 @@
         </p:nvGrpSpPr>
         <p:grpSpPr>
           <a:xfrm>
-            <a:off x="4176540" y="1370648"/>
+            <a:off x="4855438" y="3189923"/>
             <a:ext cx="5090211" cy="2995720"/>
             <a:chOff x="4748040" y="2795588"/>
             <a:chExt cx="5090211" cy="2995720"/>
@@ -4642,54 +4642,450 @@
       </p:grpSpPr>
       <p:sp>
         <p:nvSpPr>
-          <p:cNvPr id="2" name="Title 1">
-            <a:extLst>
-              <a:ext uri="{FF2B5EF4-FFF2-40B4-BE49-F238E27FC236}">
-                <a16:creationId xmlns:a16="http://schemas.microsoft.com/office/drawing/2014/main" id="{6BF02AED-8459-67E4-F4E5-E5403E56DDB9}"/>
-              </a:ext>
-            </a:extLst>
-          </p:cNvPr>
-          <p:cNvSpPr>
-            <a:spLocks noGrp="1"/>
-          </p:cNvSpPr>
-          <p:nvPr>
-            <p:ph type="title"/>
-          </p:nvPr>
-        </p:nvSpPr>
-        <p:spPr/>
-        <p:txBody>
-          <a:bodyPr/>
+          <p:cNvPr id="34" name="Rectangle 33">
+            <a:extLst>
+              <a:ext uri="{FF2B5EF4-FFF2-40B4-BE49-F238E27FC236}">
+                <a16:creationId xmlns:a16="http://schemas.microsoft.com/office/drawing/2014/main" id="{7EEA5879-718B-E71F-3E53-4F1EF6C8D754}"/>
+              </a:ext>
+            </a:extLst>
+          </p:cNvPr>
+          <p:cNvSpPr/>
+          <p:nvPr/>
+        </p:nvSpPr>
+        <p:spPr>
+          <a:xfrm>
+            <a:off x="2590953" y="2219326"/>
+            <a:ext cx="7781774" cy="191514"/>
+          </a:xfrm>
+          <a:prstGeom prst="rect">
+            <a:avLst/>
+          </a:prstGeom>
+          <a:solidFill>
+            <a:srgbClr val="257C5B"/>
+          </a:solidFill>
+          <a:ln>
+            <a:noFill/>
+          </a:ln>
+        </p:spPr>
+        <p:style>
+          <a:lnRef idx="2">
+            <a:schemeClr val="accent1">
+              <a:shade val="15000"/>
+            </a:schemeClr>
+          </a:lnRef>
+          <a:fillRef idx="1">
+            <a:schemeClr val="accent1"/>
+          </a:fillRef>
+          <a:effectRef idx="0">
+            <a:schemeClr val="accent1"/>
+          </a:effectRef>
+          <a:fontRef idx="minor">
+            <a:schemeClr val="lt1"/>
+          </a:fontRef>
+        </p:style>
+        <p:txBody>
+          <a:bodyPr rtlCol="0" anchor="ctr"/>
           <a:lstStyle/>
           <a:p>
+            <a:pPr algn="ctr"/>
             <a:endParaRPr lang="en-US"/>
           </a:p>
         </p:txBody>
       </p:sp>
-      <p:sp>
-        <p:nvSpPr>
-          <p:cNvPr id="3" name="Content Placeholder 2">
-            <a:extLst>
-              <a:ext uri="{FF2B5EF4-FFF2-40B4-BE49-F238E27FC236}">
-                <a16:creationId xmlns:a16="http://schemas.microsoft.com/office/drawing/2014/main" id="{4E7AD887-4104-96D7-4645-98711EAC6609}"/>
-              </a:ext>
-            </a:extLst>
-          </p:cNvPr>
-          <p:cNvSpPr>
-            <a:spLocks noGrp="1"/>
-          </p:cNvSpPr>
-          <p:nvPr>
-            <p:ph idx="1"/>
-          </p:nvPr>
-        </p:nvSpPr>
-        <p:spPr/>
-        <p:txBody>
-          <a:bodyPr/>
-          <a:lstStyle/>
-          <a:p>
-            <a:endParaRPr lang="en-US"/>
-          </a:p>
-        </p:txBody>
-      </p:sp>
+      <p:grpSp>
+        <p:nvGrpSpPr>
+          <p:cNvPr id="22" name="Group 21">
+            <a:extLst>
+              <a:ext uri="{FF2B5EF4-FFF2-40B4-BE49-F238E27FC236}">
+                <a16:creationId xmlns:a16="http://schemas.microsoft.com/office/drawing/2014/main" id="{E26DE27A-D86C-A813-7A71-C4AFE58D2B32}"/>
+              </a:ext>
+            </a:extLst>
+          </p:cNvPr>
+          <p:cNvGrpSpPr/>
+          <p:nvPr/>
+        </p:nvGrpSpPr>
+        <p:grpSpPr>
+          <a:xfrm>
+            <a:off x="2590953" y="1677744"/>
+            <a:ext cx="7781773" cy="733096"/>
+            <a:chOff x="2590953" y="1677744"/>
+            <a:chExt cx="7781773" cy="733096"/>
+          </a:xfrm>
+        </p:grpSpPr>
+        <p:grpSp>
+          <p:nvGrpSpPr>
+            <p:cNvPr id="5" name="Group 4">
+              <a:extLst>
+                <a:ext uri="{FF2B5EF4-FFF2-40B4-BE49-F238E27FC236}">
+                  <a16:creationId xmlns:a16="http://schemas.microsoft.com/office/drawing/2014/main" id="{D38C1CF3-0D7E-4982-7A5C-D9DC537D2983}"/>
+                </a:ext>
+              </a:extLst>
+            </p:cNvPr>
+            <p:cNvGrpSpPr/>
+            <p:nvPr/>
+          </p:nvGrpSpPr>
+          <p:grpSpPr>
+            <a:xfrm rot="5400000">
+              <a:off x="6211049" y="-1942352"/>
+              <a:ext cx="541581" cy="7781773"/>
+              <a:chOff x="4748040" y="2838449"/>
+              <a:chExt cx="1138409" cy="2905126"/>
+            </a:xfrm>
+          </p:grpSpPr>
+          <p:pic>
+            <p:nvPicPr>
+              <p:cNvPr id="7" name="Picture 6">
+                <a:extLst>
+                  <a:ext uri="{FF2B5EF4-FFF2-40B4-BE49-F238E27FC236}">
+                    <a16:creationId xmlns:a16="http://schemas.microsoft.com/office/drawing/2014/main" id="{E1AA0EAD-FB1C-D036-12FE-09740A569EB2}"/>
+                  </a:ext>
+                </a:extLst>
+              </p:cNvPr>
+              <p:cNvPicPr>
+                <a:picLocks noChangeAspect="1"/>
+              </p:cNvPicPr>
+              <p:nvPr/>
+            </p:nvPicPr>
+            <p:blipFill>
+              <a:blip r:embed="rId2"/>
+              <a:srcRect l="14032" t="2555"/>
+              <a:stretch>
+                <a:fillRect/>
+              </a:stretch>
+            </p:blipFill>
+            <p:spPr>
+              <a:xfrm>
+                <a:off x="5681709" y="2838449"/>
+                <a:ext cx="204740" cy="2905126"/>
+              </a:xfrm>
+              <a:prstGeom prst="rect">
+                <a:avLst/>
+              </a:prstGeom>
+            </p:spPr>
+          </p:pic>
+          <p:pic>
+            <p:nvPicPr>
+              <p:cNvPr id="8" name="Picture 7">
+                <a:extLst>
+                  <a:ext uri="{FF2B5EF4-FFF2-40B4-BE49-F238E27FC236}">
+                    <a16:creationId xmlns:a16="http://schemas.microsoft.com/office/drawing/2014/main" id="{AA5E8103-B0BE-6341-56BD-8E8B49BBB6C7}"/>
+                  </a:ext>
+                </a:extLst>
+              </p:cNvPr>
+              <p:cNvPicPr>
+                <a:picLocks noChangeAspect="1"/>
+              </p:cNvPicPr>
+              <p:nvPr/>
+            </p:nvPicPr>
+            <p:blipFill>
+              <a:blip r:embed="rId2"/>
+              <a:srcRect l="14032" t="2555"/>
+              <a:stretch>
+                <a:fillRect/>
+              </a:stretch>
+            </p:blipFill>
+            <p:spPr>
+              <a:xfrm rot="10800000" flipV="1">
+                <a:off x="5476969" y="2838449"/>
+                <a:ext cx="204740" cy="2905126"/>
+              </a:xfrm>
+              <a:prstGeom prst="rect">
+                <a:avLst/>
+              </a:prstGeom>
+            </p:spPr>
+          </p:pic>
+          <p:pic>
+            <p:nvPicPr>
+              <p:cNvPr id="9" name="Picture 8">
+                <a:extLst>
+                  <a:ext uri="{FF2B5EF4-FFF2-40B4-BE49-F238E27FC236}">
+                    <a16:creationId xmlns:a16="http://schemas.microsoft.com/office/drawing/2014/main" id="{37B61B16-A9D8-CFFB-FEF3-04C1844D9E48}"/>
+                  </a:ext>
+                </a:extLst>
+              </p:cNvPr>
+              <p:cNvPicPr>
+                <a:picLocks noChangeAspect="1"/>
+              </p:cNvPicPr>
+              <p:nvPr/>
+            </p:nvPicPr>
+            <p:blipFill>
+              <a:blip r:embed="rId2"/>
+              <a:srcRect l="14032" t="2555"/>
+              <a:stretch>
+                <a:fillRect/>
+              </a:stretch>
+            </p:blipFill>
+            <p:spPr>
+              <a:xfrm rot="10800000" flipH="1" flipV="1">
+                <a:off x="5281464" y="2838449"/>
+                <a:ext cx="204740" cy="2905126"/>
+              </a:xfrm>
+              <a:prstGeom prst="rect">
+                <a:avLst/>
+              </a:prstGeom>
+            </p:spPr>
+          </p:pic>
+          <p:pic>
+            <p:nvPicPr>
+              <p:cNvPr id="10" name="Picture 9">
+                <a:extLst>
+                  <a:ext uri="{FF2B5EF4-FFF2-40B4-BE49-F238E27FC236}">
+                    <a16:creationId xmlns:a16="http://schemas.microsoft.com/office/drawing/2014/main" id="{18F56E5C-94DA-C3C8-EA55-83EBA179AA52}"/>
+                  </a:ext>
+                </a:extLst>
+              </p:cNvPr>
+              <p:cNvPicPr>
+                <a:picLocks noChangeAspect="1"/>
+              </p:cNvPicPr>
+              <p:nvPr/>
+            </p:nvPicPr>
+            <p:blipFill>
+              <a:blip r:embed="rId2"/>
+              <a:srcRect l="14032" t="2555"/>
+              <a:stretch>
+                <a:fillRect/>
+              </a:stretch>
+            </p:blipFill>
+            <p:spPr>
+              <a:xfrm rot="10800000" flipV="1">
+                <a:off x="5122708" y="2838449"/>
+                <a:ext cx="204740" cy="2905126"/>
+              </a:xfrm>
+              <a:prstGeom prst="rect">
+                <a:avLst/>
+              </a:prstGeom>
+            </p:spPr>
+          </p:pic>
+          <p:pic>
+            <p:nvPicPr>
+              <p:cNvPr id="11" name="Picture 10">
+                <a:extLst>
+                  <a:ext uri="{FF2B5EF4-FFF2-40B4-BE49-F238E27FC236}">
+                    <a16:creationId xmlns:a16="http://schemas.microsoft.com/office/drawing/2014/main" id="{ECC86433-7B9F-88EA-3468-DECDC8628827}"/>
+                  </a:ext>
+                </a:extLst>
+              </p:cNvPr>
+              <p:cNvPicPr>
+                <a:picLocks noChangeAspect="1"/>
+              </p:cNvPicPr>
+              <p:nvPr/>
+            </p:nvPicPr>
+            <p:blipFill>
+              <a:blip r:embed="rId2"/>
+              <a:srcRect l="14032" t="2555"/>
+              <a:stretch>
+                <a:fillRect/>
+              </a:stretch>
+            </p:blipFill>
+            <p:spPr>
+              <a:xfrm rot="10800000" flipH="1" flipV="1">
+                <a:off x="4945577" y="2838449"/>
+                <a:ext cx="204740" cy="2905126"/>
+              </a:xfrm>
+              <a:prstGeom prst="rect">
+                <a:avLst/>
+              </a:prstGeom>
+            </p:spPr>
+          </p:pic>
+          <p:pic>
+            <p:nvPicPr>
+              <p:cNvPr id="12" name="Picture 11">
+                <a:extLst>
+                  <a:ext uri="{FF2B5EF4-FFF2-40B4-BE49-F238E27FC236}">
+                    <a16:creationId xmlns:a16="http://schemas.microsoft.com/office/drawing/2014/main" id="{80F00E95-31F8-7CFA-C6CE-6434DAECE0B3}"/>
+                  </a:ext>
+                </a:extLst>
+              </p:cNvPr>
+              <p:cNvPicPr>
+                <a:picLocks noChangeAspect="1"/>
+              </p:cNvPicPr>
+              <p:nvPr/>
+            </p:nvPicPr>
+            <p:blipFill>
+              <a:blip r:embed="rId2"/>
+              <a:srcRect l="14032" t="2555"/>
+              <a:stretch>
+                <a:fillRect/>
+              </a:stretch>
+            </p:blipFill>
+            <p:spPr>
+              <a:xfrm rot="10800000" flipV="1">
+                <a:off x="4748040" y="2838449"/>
+                <a:ext cx="204740" cy="2905126"/>
+              </a:xfrm>
+              <a:prstGeom prst="rect">
+                <a:avLst/>
+              </a:prstGeom>
+            </p:spPr>
+          </p:pic>
+        </p:grpSp>
+        <p:pic>
+          <p:nvPicPr>
+            <p:cNvPr id="20" name="Picture 19">
+              <a:extLst>
+                <a:ext uri="{FF2B5EF4-FFF2-40B4-BE49-F238E27FC236}">
+                  <a16:creationId xmlns:a16="http://schemas.microsoft.com/office/drawing/2014/main" id="{03D1084E-DDAB-E052-D3E9-6739D54738B8}"/>
+                </a:ext>
+              </a:extLst>
+            </p:cNvPr>
+            <p:cNvPicPr>
+              <a:picLocks noChangeAspect="1"/>
+            </p:cNvPicPr>
+            <p:nvPr/>
+          </p:nvPicPr>
+          <p:blipFill>
+            <a:blip r:embed="rId3"/>
+            <a:stretch>
+              <a:fillRect/>
+            </a:stretch>
+          </p:blipFill>
+          <p:spPr>
+            <a:xfrm>
+              <a:off x="2781453" y="1833006"/>
+              <a:ext cx="590395" cy="577834"/>
+            </a:xfrm>
+            <a:prstGeom prst="rect">
+              <a:avLst/>
+            </a:prstGeom>
+          </p:spPr>
+        </p:pic>
+        <p:sp>
+          <p:nvSpPr>
+            <p:cNvPr id="21" name="TextBox 20">
+              <a:extLst>
+                <a:ext uri="{FF2B5EF4-FFF2-40B4-BE49-F238E27FC236}">
+                  <a16:creationId xmlns:a16="http://schemas.microsoft.com/office/drawing/2014/main" id="{06F52EC9-9752-4B7D-E24B-A0E1F5E33381}"/>
+                </a:ext>
+              </a:extLst>
+            </p:cNvPr>
+            <p:cNvSpPr txBox="1"/>
+            <p:nvPr/>
+          </p:nvSpPr>
+          <p:spPr>
+            <a:xfrm>
+              <a:off x="3371848" y="1791845"/>
+              <a:ext cx="3600858" cy="584775"/>
+            </a:xfrm>
+            <a:prstGeom prst="rect">
+              <a:avLst/>
+            </a:prstGeom>
+            <a:noFill/>
+          </p:spPr>
+          <p:txBody>
+            <a:bodyPr wrap="none" rtlCol="0">
+              <a:spAutoFit/>
+            </a:bodyPr>
+            <a:lstStyle/>
+            <a:p>
+              <a:r>
+                <a:rPr lang="en-US" sz="3200" b="1" dirty="0">
+                  <a:solidFill>
+                    <a:srgbClr val="FFFFFF"/>
+                  </a:solidFill>
+                </a:rPr>
+                <a:t>Completeness Chart</a:t>
+              </a:r>
+              <a:endParaRPr lang="en-US" b="1" dirty="0">
+                <a:solidFill>
+                  <a:srgbClr val="FFFFFF"/>
+                </a:solidFill>
+              </a:endParaRPr>
+            </a:p>
+          </p:txBody>
+        </p:sp>
+      </p:grpSp>
+      <p:pic>
+        <p:nvPicPr>
+          <p:cNvPr id="33" name="Picture 32">
+            <a:extLst>
+              <a:ext uri="{FF2B5EF4-FFF2-40B4-BE49-F238E27FC236}">
+                <a16:creationId xmlns:a16="http://schemas.microsoft.com/office/drawing/2014/main" id="{EB791395-72CE-4887-9DA5-E11732254118}"/>
+              </a:ext>
+            </a:extLst>
+          </p:cNvPr>
+          <p:cNvPicPr>
+            <a:picLocks noChangeAspect="1"/>
+          </p:cNvPicPr>
+          <p:nvPr/>
+        </p:nvPicPr>
+        <p:blipFill>
+          <a:blip r:embed="rId4"/>
+          <a:stretch>
+            <a:fillRect/>
+          </a:stretch>
+        </p:blipFill>
+        <p:spPr>
+          <a:xfrm>
+            <a:off x="2203366" y="2980905"/>
+            <a:ext cx="7785267" cy="896190"/>
+          </a:xfrm>
+          <a:prstGeom prst="rect">
+            <a:avLst/>
+          </a:prstGeom>
+        </p:spPr>
+      </p:pic>
+      <p:pic>
+        <p:nvPicPr>
+          <p:cNvPr id="46" name="Picture 45">
+            <a:extLst>
+              <a:ext uri="{FF2B5EF4-FFF2-40B4-BE49-F238E27FC236}">
+                <a16:creationId xmlns:a16="http://schemas.microsoft.com/office/drawing/2014/main" id="{F78730DF-A9F2-1403-45C0-2FD1375C231D}"/>
+              </a:ext>
+            </a:extLst>
+          </p:cNvPr>
+          <p:cNvPicPr>
+            <a:picLocks noChangeAspect="1"/>
+          </p:cNvPicPr>
+          <p:nvPr/>
+        </p:nvPicPr>
+        <p:blipFill>
+          <a:blip r:embed="rId5"/>
+          <a:srcRect b="17484"/>
+          <a:stretch>
+            <a:fillRect/>
+          </a:stretch>
+        </p:blipFill>
+        <p:spPr>
+          <a:xfrm>
+            <a:off x="2131479" y="4634759"/>
+            <a:ext cx="7785267" cy="739498"/>
+          </a:xfrm>
+          <a:prstGeom prst="rect">
+            <a:avLst/>
+          </a:prstGeom>
+        </p:spPr>
+      </p:pic>
+      <p:pic>
+        <p:nvPicPr>
+          <p:cNvPr id="37" name="Picture 36">
+            <a:extLst>
+              <a:ext uri="{FF2B5EF4-FFF2-40B4-BE49-F238E27FC236}">
+                <a16:creationId xmlns:a16="http://schemas.microsoft.com/office/drawing/2014/main" id="{568B0C4D-3D23-6BBB-D92E-C4A29F76E30B}"/>
+              </a:ext>
+            </a:extLst>
+          </p:cNvPr>
+          <p:cNvPicPr>
+            <a:picLocks noChangeAspect="1"/>
+          </p:cNvPicPr>
+          <p:nvPr/>
+        </p:nvPicPr>
+        <p:blipFill>
+          <a:blip r:embed="rId6"/>
+          <a:srcRect b="17484"/>
+          <a:stretch>
+            <a:fillRect/>
+          </a:stretch>
+        </p:blipFill>
+        <p:spPr>
+          <a:xfrm>
+            <a:off x="1855434" y="598103"/>
+            <a:ext cx="7785267" cy="739498"/>
+          </a:xfrm>
+          <a:prstGeom prst="rect">
+            <a:avLst/>
+          </a:prstGeom>
+        </p:spPr>
+      </p:pic>
     </p:spTree>
     <p:extLst>
       <p:ext uri="{BB962C8B-B14F-4D97-AF65-F5344CB8AC3E}">

</xml_diff>